<commit_message>
Submission prep: README polish, ER diagram source, drop internal docs
README.md:
  - fix database.db size (1.4 MB -> 2.2 MB)
  - rewrite File-structure tree (remove deleted internal docs, add
    er_diagram.md, full visualizations/ breakdown, .gitignore line)
  - replace [username] GitHub placeholder with submission-contents note
  - embed two more figures (drivers_grid, burden_capacity_scatter) so
    4 of 5 visualizations are inline in the README

schema/er_diagram.md: mermaid source of truth for er_diagram.png,
with cardinality reference and visual conventions.

docs/data_cleaning_report.md: drop dangling reference to deleted
presentation_talking_points.md.

Deletions: docs/presentation_script.md, docs/presentation_talking_points.md
(internal authoring drafts, superseded by presentation.pptx).

presentation.pptx: minor edits saved with deck.

.gitignore: exclude Round_1_Hackathon_Instructions.docx (hackathon
reference material, not project content).
</commit_message>
<xml_diff>
--- a/presentation.pptx
+++ b/presentation.pptx
@@ -511,7 +511,7 @@
             <a:r>
               <a:rPr lang="en-US" dirty="0"/>
               <a:t>Good afternoon. I'm Nhoojah Maharjan, a student at the University of Southern Mississippi.
-Over the past 48 hours I built the Mississippi Health Equity Gap Index — a county-level composite that ranks all 82 Mississippi counties by underservedness, combining three federally-sourced inputs.
+I built the Mississippi Health Equity Gap Index — a county-level composite that ranks all 82 Mississippi counties by underservedness, combining three federally-sourced inputs.
 Let me show you the headline finding.
 Target: ~12 seconds. Calm, steady opening — don't rush.</a:t>
             </a:r>
@@ -878,7 +878,7 @@
               <a:rPr lang="en-US" dirty="0"/>
               <a:t>The Equity Gap Index is one-third burden plus one-third capacity plus one-third vulnerability, where each component is normalized to a zero-to-100 scale across Mississippi counties.
 Burden is a polarity-aware average of 10 PLACES measures. Capacity is primary-care providers per ten thousand residents, inverted. Vulnerability is the SVI intra-state percentile.
-Equal weights follow the County Health Rankings convention — we considered three alternative weighting schemes and rejected each. In a 48-hour analysis without formal stakeholder elicitation, equal weights are the only fully defensible choice. The full math lives in one SQL file.
+Equal weights follow the County Health Rankings convention — we considered three alternative weighting schemes and rejected each. Without a formal stakeholder-elicitation process, equal weights are the most defensible choice. The full math lives in one SQL file.
 Target: ~40 seconds. Q&amp;A defensive: the three rejected alternatives were PCA-derived weights (needed stakeholder validation), inverse-correlation weights (overcorrects), and burden-double weighting (no theoretical basis).</a:t>
             </a:r>
             <a:endParaRPr lang="en-US" dirty="0"/>
@@ -1149,13 +1149,13 @@
           <a:p>
             <a:r>
               <a:rPr lang="en-US" dirty="0"/>
-              <a:t>Four concrete uses for the Gulf South Center.
-First — prioritization: a one-page county ranking with all three components visible, ready for a steering committee.
-Second — longitudinal tracking: the pipeline regenerates from the latest federal data in 10 seconds, so this index updates as PLACES, SVI, and HRSA update annually.
-Third — defensible advocacy: when the Center allocates resources, the receipts are right there. Three federal datasets, traceable methodology, every decision numbered and logged.
-Fourth — methodology, not just numbers. The codebase is a starting point if the Center ever extends the index to other Gulf South states. Alabama, Louisiana, Arkansas all have the same federal inputs available.
-Built in 48 hours, solo, with no prior Mississippi public-health background. [BEAT] With a summer at the Gulf South Center, this is the kind of work I want to do at depth.
-Target: ~50 seconds. The closing sentence is the appeal-to-mission moment. Deliver it with conviction. Pause after 'no prior Mississippi public-health background' — the implication is what carries the line.</a:t>
+              <a:t>Four concrete things this index gives the Gulf South Center.
+First — decision-ready ranking. All 82 counties, each with the three component scores visible. Open one CSV, see priority order plus the reason for that priority.
+Second — reproducible by design. The full pipeline regenerates from raw federal data in a single command. As PLACES, SVI, and HRSA update annually, the index updates with them — no rebuild needed.
+Third — traceable methodology. Every analytical decision logged with rationale. When the Center allocates resources, the receipts are right there — three federal datasets, transparent math, no black box.
+Fourth — extensible foundation. Add specialty-care taxonomies, swap rural classification for USDA RUCC, extend to Alabama, Louisiana, Arkansas. The codebase is a starting point, not a black box.
+Three concrete next steps would make this a working tool: stakeholder-elicited weights to replace the equal-thirds default, a multi-year time series to surface trends, and sub-county breakdowns by age and race where the underlying data supports it. [BEAT] That's the work I'd want to do at the Gulf South Center.
+Target: ~50 seconds. The closing sentence is the appeal-to-mission moment. Deliver the 'three concrete next steps' confidently — these are real, defensible technical roadmap items. Pause before 'That's the work I'd want to do' so it lands as a deliberate close, not a throwaway.</a:t>
             </a:r>
             <a:endParaRPr lang="en-US" dirty="0"/>
           </a:p>
@@ -1651,8 +1651,8 @@
         </p:nvSpPr>
         <p:spPr>
           <a:xfrm>
-            <a:off x="914400" y="1143000"/>
-            <a:ext cx="10058400" cy="365760"/>
+            <a:off x="914400" y="2103120"/>
+            <a:ext cx="10058400" cy="1188720"/>
           </a:xfrm>
           <a:prstGeom prst="rect">
             <a:avLst/>
@@ -1668,7 +1668,7 @@
               <a:buNone/>
             </a:pPr>
             <a:r>
-              <a:rPr lang="en-US" sz="1300" b="1" spc="600" kern="0" dirty="0">
+              <a:rPr lang="en-US" sz="5000" b="1" dirty="0">
                 <a:solidFill>
                   <a:srgbClr val="0D4F5C"/>
                 </a:solidFill>
@@ -1676,9 +1676,9 @@
                 <a:ea typeface="Calibri" pitchFamily="34" charset="-122"/>
                 <a:cs typeface="Calibri" pitchFamily="34" charset="-120"/>
               </a:rPr>
-              <a:t>GULF SOUTH CENTER  ·  ROUND 1 HACKATHON</a:t>
-            </a:r>
-            <a:endParaRPr lang="en-US" sz="1300" dirty="0"/>
+              <a:t>Mississippi Health Equity Gap Index</a:t>
+            </a:r>
+            <a:endParaRPr lang="en-US" sz="5000" dirty="0"/>
           </a:p>
         </p:txBody>
       </p:sp>
@@ -1690,8 +1690,8 @@
         </p:nvSpPr>
         <p:spPr>
           <a:xfrm>
-            <a:off x="914400" y="1691640"/>
-            <a:ext cx="10058400" cy="1920240"/>
+            <a:off x="914400" y="3337560"/>
+            <a:ext cx="9601200" cy="914400"/>
           </a:xfrm>
           <a:prstGeom prst="rect">
             <a:avLst/>
@@ -1707,45 +1707,6 @@
               <a:buNone/>
             </a:pPr>
             <a:r>
-              <a:rPr lang="en-US" sz="4800" b="1" dirty="0">
-                <a:solidFill>
-                  <a:srgbClr val="0D4F5C"/>
-                </a:solidFill>
-                <a:latin typeface="Calibri" pitchFamily="34" charset="0"/>
-                <a:ea typeface="Calibri" pitchFamily="34" charset="-122"/>
-                <a:cs typeface="Calibri" pitchFamily="34" charset="-120"/>
-              </a:rPr>
-              <a:t>Mississippi Health Equity Gap Index</a:t>
-            </a:r>
-            <a:endParaRPr lang="en-US" sz="4800" dirty="0"/>
-          </a:p>
-        </p:txBody>
-      </p:sp>
-      <p:sp>
-        <p:nvSpPr>
-          <p:cNvPr id="5" name="Text 3"/>
-          <p:cNvSpPr/>
-          <p:nvPr/>
-        </p:nvSpPr>
-        <p:spPr>
-          <a:xfrm>
-            <a:off x="914400" y="3703320"/>
-            <a:ext cx="9601200" cy="1005840"/>
-          </a:xfrm>
-          <a:prstGeom prst="rect">
-            <a:avLst/>
-          </a:prstGeom>
-          <a:noFill/>
-          <a:ln/>
-        </p:spPr>
-        <p:txBody>
-          <a:bodyPr wrap="square" lIns="0" tIns="0" rIns="0" bIns="0" rtlCol="0" anchor="t"/>
-          <a:lstStyle/>
-          <a:p>
-            <a:pPr algn="l" indent="0" marL="0">
-              <a:buNone/>
-            </a:pPr>
-            <a:r>
               <a:rPr lang="en-US" sz="1800" dirty="0">
                 <a:solidFill>
                   <a:srgbClr val="5A5A5A"/>
@@ -1762,7 +1723,7 @@
       </p:sp>
       <p:sp>
         <p:nvSpPr>
-          <p:cNvPr id="6" name="Shape 4"/>
+          <p:cNvPr id="5" name="Shape 3"/>
           <p:cNvSpPr/>
           <p:nvPr/>
         </p:nvSpPr>
@@ -1785,7 +1746,7 @@
       </p:sp>
       <p:sp>
         <p:nvSpPr>
-          <p:cNvPr id="7" name="Text 5"/>
+          <p:cNvPr id="6" name="Text 4"/>
           <p:cNvSpPr/>
           <p:nvPr/>
         </p:nvSpPr>
@@ -1824,7 +1785,7 @@
       </p:sp>
       <p:sp>
         <p:nvSpPr>
-          <p:cNvPr id="8" name="Text 6"/>
+          <p:cNvPr id="7" name="Text 5"/>
           <p:cNvSpPr/>
           <p:nvPr/>
         </p:nvSpPr>
@@ -1863,7 +1824,7 @@
       </p:sp>
       <p:sp>
         <p:nvSpPr>
-          <p:cNvPr id="9" name="Text 7"/>
+          <p:cNvPr id="8" name="Text 6"/>
           <p:cNvSpPr/>
           <p:nvPr/>
         </p:nvSpPr>
@@ -5101,7 +5062,7 @@
                 <a:ea typeface="Calibri" pitchFamily="34" charset="-122"/>
                 <a:cs typeface="Calibri" pitchFamily="34" charset="-120"/>
               </a:rPr>
-              <a:t>Each component is min-max normalized to 0–100 across Mississippi counties. Equal weights follow the County Health Rankings convention — we considered three alternative weighting schemes and rejected each. In a 48-hour analysis without stakeholder elicitation, equal weights are the only fully defensible choice.</a:t>
+              <a:t>Each component is min-max normalized to 0–100 across Mississippi counties. Equal weights follow the County Health Rankings convention — we considered three alternative weighting schemes and rejected each. Without a formal stakeholder-elicitation process, equal weights are the most defensible choice.</a:t>
             </a:r>
             <a:endParaRPr lang="en-US" sz="1200" dirty="0"/>
           </a:p>
@@ -6074,7 +6035,7 @@
                 <a:ea typeface="Calibri" pitchFamily="34" charset="-122"/>
                 <a:cs typeface="Calibri" pitchFamily="34" charset="-120"/>
               </a:rPr>
-              <a:t>What this means for the Gulf South Center</a:t>
+              <a:t>What's in it for the Gulf South Center</a:t>
             </a:r>
             <a:endParaRPr lang="en-US" sz="3200" dirty="0"/>
           </a:p>
@@ -6254,7 +6215,7 @@
                 <a:ea typeface="Calibri" pitchFamily="34" charset="-122"/>
                 <a:cs typeface="Calibri" pitchFamily="34" charset="-120"/>
               </a:rPr>
-              <a:t>Prioritization</a:t>
+              <a:t>Decision-ready ranking</a:t>
             </a:r>
             <a:endParaRPr lang="en-US" sz="1600" dirty="0"/>
           </a:p>
@@ -6293,7 +6254,7 @@
                 <a:ea typeface="Calibri" pitchFamily="34" charset="-122"/>
                 <a:cs typeface="Calibri" pitchFamily="34" charset="-120"/>
               </a:rPr>
-              <a:t>A one-page county ranking with all three components visible — ready for a steering committee meeting.</a:t>
+              <a:t>All 82 counties ranked, with each component visible per county. A steering committee can open one CSV and see priority order plus the reason for the priority.</a:t>
             </a:r>
             <a:endParaRPr lang="en-US" sz="1200" dirty="0"/>
           </a:p>
@@ -6372,7 +6333,7 @@
                 <a:ea typeface="Calibri" pitchFamily="34" charset="-122"/>
                 <a:cs typeface="Calibri" pitchFamily="34" charset="-120"/>
               </a:rPr>
-              <a:t>Longitudinal tracking</a:t>
+              <a:t>Reproducible by design</a:t>
             </a:r>
             <a:endParaRPr lang="en-US" sz="1600" dirty="0"/>
           </a:p>
@@ -6411,7 +6372,7 @@
                 <a:ea typeface="Calibri" pitchFamily="34" charset="-122"/>
                 <a:cs typeface="Calibri" pitchFamily="34" charset="-120"/>
               </a:rPr>
-              <a:t>The pipeline regenerates from the latest federal data in ~10 seconds, so the index updates as PLACES, SVI, and HRSA update annually.</a:t>
+              <a:t>The full pipeline regenerates from raw federal data in a single command. As PLACES, SVI, and HRSA update annually, the index updates with them.</a:t>
             </a:r>
             <a:endParaRPr lang="en-US" sz="1200" dirty="0"/>
           </a:p>
@@ -6490,7 +6451,7 @@
                 <a:ea typeface="Calibri" pitchFamily="34" charset="-122"/>
                 <a:cs typeface="Calibri" pitchFamily="34" charset="-120"/>
               </a:rPr>
-              <a:t>Defensible advocacy</a:t>
+              <a:t>Traceable methodology</a:t>
             </a:r>
             <a:endParaRPr lang="en-US" sz="1600" dirty="0"/>
           </a:p>
@@ -6529,7 +6490,7 @@
                 <a:ea typeface="Calibri" pitchFamily="34" charset="-122"/>
                 <a:cs typeface="Calibri" pitchFamily="34" charset="-120"/>
               </a:rPr>
-              <a:t>When the Center allocates resources, the receipts are right there: three federal datasets, traceable methodology, every decision numbered and logged.</a:t>
+              <a:t>Every analytical decision logged with rationale. When the Center allocates resources, the receipts are right there — three federal datasets, transparent math, no black box.</a:t>
             </a:r>
             <a:endParaRPr lang="en-US" sz="1200" dirty="0"/>
           </a:p>
@@ -6608,7 +6569,7 @@
                 <a:ea typeface="Calibri" pitchFamily="34" charset="-122"/>
                 <a:cs typeface="Calibri" pitchFamily="34" charset="-120"/>
               </a:rPr>
-              <a:t>Methodology, not just numbers</a:t>
+              <a:t>Extensible foundation</a:t>
             </a:r>
             <a:endParaRPr lang="en-US" sz="1600" dirty="0"/>
           </a:p>
@@ -6647,7 +6608,7 @@
                 <a:ea typeface="Calibri" pitchFamily="34" charset="-122"/>
                 <a:cs typeface="Calibri" pitchFamily="34" charset="-120"/>
               </a:rPr>
-              <a:t>The codebase is a starting point if the Center ever extends the index to other Gulf South states — AL, LA, AR all have the same federal inputs.</a:t>
+              <a:t>The codebase is a starting point. Add specialty-care taxonomies, swap rural classification for USDA RUCC, extend to AL, LA, AR — the federal inputs are the same.</a:t>
             </a:r>
             <a:endParaRPr lang="en-US" sz="1200" dirty="0"/>
           </a:p>
@@ -6703,7 +6664,7 @@
               <a:buNone/>
             </a:pPr>
             <a:r>
-              <a:rPr lang="en-US" sz="1400" dirty="0">
+              <a:rPr lang="en-US" sz="1200" dirty="0">
                 <a:solidFill>
                   <a:srgbClr val="1A1A1A"/>
                 </a:solidFill>
@@ -6711,13 +6672,13 @@
                 <a:ea typeface="Calibri" pitchFamily="34" charset="-122"/>
                 <a:cs typeface="Calibri" pitchFamily="34" charset="-120"/>
               </a:rPr>
-              <a:t>Built in 48 hours, solo, with no prior Mississippi public-health background. </a:t>
+              <a:t>Three concrete next steps would make this a working tool: stakeholder-elicited weights to replace the equal-thirds default, a multi-year time series to surface trends, and sub-county breakdowns by age and race where the underlying data supports it. </a:t>
             </a:r>
             <a:pPr algn="l" indent="0" marL="0">
               <a:buNone/>
             </a:pPr>
             <a:r>
-              <a:rPr lang="en-US" sz="1400" b="1" dirty="0">
+              <a:rPr lang="en-US" sz="1200" b="1" dirty="0">
                 <a:solidFill>
                   <a:srgbClr val="0D4F5C"/>
                 </a:solidFill>
@@ -6725,9 +6686,9 @@
                 <a:ea typeface="Calibri" pitchFamily="34" charset="-122"/>
                 <a:cs typeface="Calibri" pitchFamily="34" charset="-120"/>
               </a:rPr>
-              <a:t>With a summer at the Gulf South Center, this is the kind of work I want to do at depth.</a:t>
-            </a:r>
-            <a:endParaRPr lang="en-US" sz="1400" dirty="0"/>
+              <a:t>That's the work I'd want to do at the Gulf South Center.</a:t>
+            </a:r>
+            <a:endParaRPr lang="en-US" sz="1200" dirty="0"/>
           </a:p>
         </p:txBody>
       </p:sp>

</xml_diff>